<commit_message>
Generated docs regenerated for the v1.11.170 arc (spec, training, walkthrough)
Content frozen at .154/.155 caught up: 20 modules (Teams row + admin
sections, module-map diagram rebuilt 14->20), SQL two-engine story,
real OrganizationType enum in the env-badge sections (Customer/
Secondary = prod, fail-closed) incl. the FAQ row, Show All Data lookup
editing, Virtual/Elastic chips, ERD N:N edges + business-first graph,
cache self-eviction, history privacy + PROD confirmations in security,
render caps in performance, stats (20.6k LOC / 73 actions / 39
components / 314 tests), log buffer 300. gen-security.js untouched
(dated June 2026 audit report - historical).

Co-Authored-By: Claude Fable 5 <noreply@anthropic.com>
</commit_message>
<xml_diff>
--- a/docs/Colvio_Walkthrough.pptx
+++ b/docs/Colvio_Walkthrough.pptx
@@ -2024,7 +2024,7 @@
                 <a:ea typeface="Calibri" pitchFamily="34" charset="-122"/>
                 <a:cs typeface="Calibri" pitchFamily="34" charset="-120"/>
               </a:rPr>
-              <a:t>Product walkthrough  ·  v1.11.154  ·  August 2026</a:t>
+              <a:t>Product walkthrough  ·  v1.11.170  ·  October 2026</a:t>
             </a:r>
             <a:endParaRPr lang="en-US" sz="1100" dirty="0"/>
           </a:p>
@@ -2193,7 +2193,7 @@
                 <a:ea typeface="Calibri" pitchFamily="34" charset="-122"/>
                 <a:cs typeface="Calibri" pitchFamily="34" charset="-120"/>
               </a:rPr>
-              <a:t>Colvio  ·  v1.11.154</a:t>
+              <a:t>Colvio  ·  v1.11.170</a:t>
             </a:r>
             <a:endParaRPr lang="en-US" sz="850" dirty="0"/>
           </a:p>
@@ -2260,7 +2260,7 @@
                 <a:ea typeface="Calibri" pitchFamily="34" charset="-122"/>
                 <a:cs typeface="Calibri" pitchFamily="34" charset="-120"/>
               </a:rPr>
-              <a:t>Full 4-dimension audit + 7-angle code review: 0 open critical/high findings</a:t>
+              <a:t>Successive audits (4-dimension, write-path, 8-lens product, pre-publication): 0 open critical/high findings</a:t>
             </a:r>
             <a:endParaRPr lang="en-US" sz="1250" dirty="0"/>
           </a:p>
@@ -2323,7 +2323,7 @@
                 <a:ea typeface="Calibri" pitchFamily="34" charset="-122"/>
                 <a:cs typeface="Calibri" pitchFamily="34" charset="-120"/>
               </a:rPr>
-              <a:t>260 automated tests</a:t>
+              <a:t>314 automated tests</a:t>
             </a:r>
             <a:endParaRPr lang="en-US" sz="1250" dirty="0"/>
           </a:p>
@@ -2492,7 +2492,7 @@
                 <a:ea typeface="Calibri" pitchFamily="34" charset="-122"/>
                 <a:cs typeface="Calibri" pitchFamily="34" charset="-120"/>
               </a:rPr>
-              <a:t>Colvio  ·  v1.11.154</a:t>
+              <a:t>Colvio  ·  v1.11.170</a:t>
             </a:r>
             <a:endParaRPr lang="en-US" sz="850" dirty="0"/>
           </a:p>
@@ -2899,7 +2899,7 @@
                 <a:ea typeface="Trebuchet MS" pitchFamily="34" charset="-122"/>
                 <a:cs typeface="Trebuchet MS" pitchFamily="34" charset="-120"/>
               </a:rPr>
-              <a:t>Login History</a:t>
+              <a:t>Teams &amp; BUs &amp; Adoption</a:t>
             </a:r>
             <a:endParaRPr lang="en-US" sz="1350" dirty="0"/>
           </a:p>
@@ -2938,7 +2938,7 @@
                 <a:ea typeface="Calibri" pitchFamily="34" charset="-122"/>
                 <a:cs typeface="Calibri" pitchFamily="34" charset="-120"/>
               </a:rPr>
-              <a:t>Login/logout timeline per user from the audit log.</a:t>
+              <a:t>Teams: members + the security roles they inherit invisibly.</a:t>
             </a:r>
             <a:endParaRPr lang="en-US" sz="1150" dirty="0"/>
           </a:p>
@@ -2961,7 +2961,7 @@
                 <a:ea typeface="Calibri" pitchFamily="34" charset="-122"/>
                 <a:cs typeface="Calibri" pitchFamily="34" charset="-120"/>
               </a:rPr>
-              <a:t>Session durations and access-type breakdown.</a:t>
+              <a:t>BUs: full org chart, bulk moves by pasted email list.</a:t>
             </a:r>
             <a:endParaRPr lang="en-US" sz="1150" dirty="0"/>
           </a:p>
@@ -2984,7 +2984,7 @@
                 <a:ea typeface="Calibri" pitchFamily="34" charset="-122"/>
                 <a:cs typeface="Calibri" pitchFamily="34" charset="-120"/>
               </a:rPr>
-              <a:t>CSV export for compliance reviews.</a:t>
+              <a:t>Adoption: DAU/WAU/MAU, PPTX report. Login history per user.</a:t>
             </a:r>
             <a:endParaRPr lang="en-US" sz="1150" dirty="0"/>
           </a:p>
@@ -3379,7 +3379,7 @@
                 <a:ea typeface="Calibri" pitchFamily="34" charset="-122"/>
                 <a:cs typeface="Calibri" pitchFamily="34" charset="-120"/>
               </a:rPr>
-              <a:t>Colvio  ·  v1.11.154</a:t>
+              <a:t>Colvio  ·  v1.11.170</a:t>
             </a:r>
             <a:endParaRPr lang="en-US" sz="850" dirty="0"/>
           </a:p>
@@ -3552,7 +3552,7 @@
                 <a:ea typeface="Trebuchet MS" pitchFamily="34" charset="-122"/>
                 <a:cs typeface="Trebuchet MS" pitchFamily="34" charset="-120"/>
               </a:rPr>
-              <a:t>19</a:t>
+              <a:t>20</a:t>
             </a:r>
             <a:endParaRPr lang="en-US" sz="4400" dirty="0"/>
           </a:p>
@@ -3872,7 +3872,7 @@
                 <a:ea typeface="Trebuchet MS" pitchFamily="34" charset="-122"/>
                 <a:cs typeface="Trebuchet MS" pitchFamily="34" charset="-120"/>
               </a:rPr>
-              <a:t>One panel, nineteen modules</a:t>
+              <a:t>One panel, twenty modules</a:t>
             </a:r>
             <a:endParaRPr lang="en-US" sz="2700" dirty="0"/>
           </a:p>
@@ -3911,7 +3911,7 @@
                 <a:ea typeface="Calibri" pitchFamily="34" charset="-122"/>
                 <a:cs typeface="Calibri" pitchFamily="34" charset="-120"/>
               </a:rPr>
-              <a:t>Colvio  ·  v1.11.154</a:t>
+              <a:t>Colvio  ·  v1.11.170</a:t>
             </a:r>
             <a:endParaRPr lang="en-US" sz="850" dirty="0"/>
           </a:p>
@@ -4104,7 +4104,7 @@
                 <a:ea typeface="Calibri" pitchFamily="34" charset="-122"/>
                 <a:cs typeface="Calibri" pitchFamily="34" charset="-120"/>
               </a:rPr>
-              <a:t>Colvio  ·  v1.11.154</a:t>
+              <a:t>Colvio  ·  v1.11.170</a:t>
             </a:r>
             <a:endParaRPr lang="en-US" sz="850" dirty="0"/>
           </a:p>
@@ -4213,7 +4213,7 @@
                 <a:ea typeface="Calibri" pitchFamily="34" charset="-122"/>
                 <a:cs typeface="Calibri" pitchFamily="34" charset="-120"/>
               </a:rPr>
-              <a:t>42 validated actions; every fetch is same-origin to your org</a:t>
+              <a:t>73 validated actions; every fetch is same-origin to your org</a:t>
             </a:r>
             <a:endParaRPr lang="en-US" sz="1250" dirty="0"/>
           </a:p>
@@ -4403,7 +4403,7 @@
                 <a:ea typeface="Calibri" pitchFamily="34" charset="-122"/>
                 <a:cs typeface="Calibri" pitchFamily="34" charset="-120"/>
               </a:rPr>
-              <a:t>Colvio  ·  v1.11.154</a:t>
+              <a:t>Colvio  ·  v1.11.170</a:t>
             </a:r>
             <a:endParaRPr lang="en-US" sz="850" dirty="0"/>
           </a:p>
@@ -4600,7 +4600,7 @@
                 <a:ea typeface="Trebuchet MS" pitchFamily="34" charset="-122"/>
                 <a:cs typeface="Trebuchet MS" pitchFamily="34" charset="-120"/>
               </a:rPr>
-              <a:t>SQL</a:t>
+              <a:t>SQL — two engines</a:t>
             </a:r>
             <a:endParaRPr lang="en-US" sz="1350" dirty="0"/>
           </a:p>
@@ -4639,7 +4639,7 @@
                 <a:ea typeface="Calibri" pitchFamily="34" charset="-122"/>
                 <a:cs typeface="Calibri" pitchFamily="34" charset="-120"/>
               </a:rPr>
-              <a:t>SELECT / JOIN / WHERE / GROUP BY / TOP — auto-translated to FetchXML: reliable pagination, link-entity joins.</a:t>
+              <a:t>Native: your SELECT runs ON Dataverse (Web API ?sql= — real JOINs with aliases, DISTINCT, GROUP BY). Transpiled: SQL→FetchXML for HAVING/TOP and older orgs.</a:t>
             </a:r>
             <a:endParaRPr lang="en-US" sz="1100" dirty="0"/>
           </a:p>
@@ -5044,7 +5044,7 @@
                 <a:ea typeface="Calibri" pitchFamily="34" charset="-122"/>
                 <a:cs typeface="Calibri" pitchFamily="34" charset="-120"/>
               </a:rPr>
-              <a:t>Colvio  ·  v1.11.154</a:t>
+              <a:t>Colvio  ·  v1.11.170</a:t>
             </a:r>
             <a:endParaRPr lang="en-US" sz="850" dirty="0"/>
           </a:p>
@@ -5504,7 +5504,7 @@
                 <a:ea typeface="Calibri" pitchFamily="34" charset="-122"/>
                 <a:cs typeface="Calibri" pitchFamily="34" charset="-120"/>
               </a:rPr>
-              <a:t>Colvio  ·  v1.11.154</a:t>
+              <a:t>Colvio  ·  v1.11.170</a:t>
             </a:r>
             <a:endParaRPr lang="en-US" sz="850" dirty="0"/>
           </a:p>
@@ -5761,7 +5761,7 @@
                 <a:ea typeface="Calibri" pitchFamily="34" charset="-122"/>
                 <a:cs typeface="Calibri" pitchFamily="34" charset="-120"/>
               </a:rPr>
-              <a:t>Colvio  ·  v1.11.154</a:t>
+              <a:t>Colvio  ·  v1.11.170</a:t>
             </a:r>
             <a:endParaRPr lang="en-US" sz="850" dirty="0"/>
           </a:p>
@@ -6141,7 +6141,7 @@
                 <a:ea typeface="Calibri" pitchFamily="34" charset="-122"/>
                 <a:cs typeface="Calibri" pitchFamily="34" charset="-120"/>
               </a:rPr>
-              <a:t>Colvio  ·  v1.11.154</a:t>
+              <a:t>Colvio  ·  v1.11.170</a:t>
             </a:r>
             <a:endParaRPr lang="en-US" sz="850" dirty="0"/>
           </a:p>

</xml_diff>